<commit_message>
docs: finalize submission materials and record cross-backend verification
</commit_message>
<xml_diff>
--- a/submission/pitch-deck.pptx
+++ b/submission/pitch-deck.pptx
@@ -581,7 +581,7 @@
           <a:lstStyle/>
           <a:p>
             <a:r>
-              <a:t>讲述重点：MoonBit 实现可复用内核。类型定义、JSON 边界校验、规则检查和回放均在 MoonBit 中实现。 编译为同一个 ES module，导出检查与缩减两个入口。 JavaScript 负责宿主输入输出与页面展示。 规则依据、创新来源及证据边界见 docs 和产品说明书。</a:t>
+              <a:t>讲述重点：MoonBit 实现可复用内核。类型定义、JSON 边界校验、规则检查和回放均在 MoonBit 中实现。 核心包可独立导入，JS 后端提供检查和两种缩减入口。 JavaScript 负责宿主输入输出与页面展示。 规则依据、创新来源及证据边界见 docs 和产品说明书。</a:t>
             </a:r>
           </a:p>
         </p:txBody>
@@ -721,7 +721,7 @@
           <a:lstStyle/>
           <a:p>
             <a:r>
-              <a:t>讲述重点：把 3 个事件缩减到 1 个。逐条尝试删除事件，并使用同一内核重新检查。 重复执行直到无法继续单条删除而保留目标违规。 结果为 1-minimal 子序列，不保证全局最短或相同根因。 规则依据、创新来源及证据边界见 docs 和产品说明书。</a:t>
+              <a:t>讲述重点：把 3 个事件缩减到 1 个。逐条尝试删除事件，并使用同一内核重新检查。 支持指定违规与调用标识，直到无法继续单条删除。 结果为 1-minimal 子序列，不保证全局最短或相同根因。 规则依据、创新来源及证据边界见 docs 和产品说明书。</a:t>
             </a:r>
           </a:p>
         </p:txBody>
@@ -791,7 +791,7 @@
           <a:lstStyle/>
           <a:p>
             <a:r>
-              <a:t>讲述重点：克隆即可复现。npm test 验证随附内核；Node CLI 直接读取示例磁带。 bash scripts/build.sh 运行核心测试、重新编译和宿主测试。 12 项 MoonBit 核心测试与宿主集成测试通过。 规则依据、创新来源及证据边界见 docs 和产品说明书。</a:t>
+              <a:t>讲述重点：克隆即可复现。npm test 验证随附内核；Node CLI 直接读取示例磁带。 bash scripts/build.sh 运行核心测试、重新编译和宿主测试。 16 项核心测试、64 组生成磁带及宿主集成验证通过。 规则依据、创新来源及证据边界见 docs 和产品说明书。</a:t>
             </a:r>
           </a:p>
         </p:txBody>
@@ -4334,8 +4334,8 @@
         </p:blipFill>
         <p:spPr>
           <a:xfrm>
-            <a:off x="3790573" y="1005840"/>
-            <a:ext cx="4610548" cy="5212080"/>
+            <a:off x="3826642" y="1005840"/>
+            <a:ext cx="4538410" cy="5212080"/>
           </a:xfrm>
           <a:prstGeom prst="rect">
             <a:avLst/>
@@ -5431,7 +5431,7 @@
               </a:defRPr>
             </a:pPr>
             <a:r>
-              <a:t>编译为同一个 ES module，导出检查与缩减两个入口。</a:t>
+              <a:t>核心包可独立导入，JS 后端提供检查和两种缩减入口。</a:t>
             </a:r>
           </a:p>
         </p:txBody>
@@ -6685,7 +6685,7 @@
               </a:defRPr>
             </a:pPr>
             <a:r>
-              <a:t>重复执行直到无法继续单条删除而保留目标违规。</a:t>
+              <a:t>支持指定违规与调用标识，直到无法继续单条删除。</a:t>
             </a:r>
           </a:p>
         </p:txBody>
@@ -7433,7 +7433,7 @@
               </a:defRPr>
             </a:pPr>
             <a:r>
-              <a:t>12 项 MoonBit 核心测试与宿主集成测试通过。</a:t>
+              <a:t>16 项核心测试、64 组生成磁带及宿主集成验证通过。</a:t>
             </a:r>
           </a:p>
         </p:txBody>

</xml_diff>